<commit_message>
Tutorial deck: file map no longer lists viz.py; add tools/compare_nasa.py
Co-authored-by: Wahengbam <ichanwaheng@users.noreply.github.com>
</commit_message>
<xml_diff>
--- a/cylinder_re150/demo/ns_staggered_tutorial.pptx
+++ b/cylinder_re150/demo/ns_staggered_tutorial.pptx
@@ -23035,7 +23035,7 @@
                     <a:p>
                       <a:r>
                         <a:rPr sz="1200" b="0"/>
-                        <a:t>solver: load_staggered, build_topology, GriebelStaggeredNS (step, _project_Un, …), plotting, CLI</a:t>
+                        <a:t>solver: load_staggered, build_topology, GriebelStaggeredNS (step, _project_Un, …), plotting, save_wake_gif, CLI</a:t>
                       </a:r>
                     </a:p>
                   </a:txBody>
@@ -23050,7 +23050,7 @@
                     <a:p>
                       <a:r>
                         <a:rPr sz="1200" b="0"/>
-                        <a:t>cylinder_re150/viz.py</a:t>
+                        <a:t>cylinder_re150/tools/compare_nasa.py</a:t>
                       </a:r>
                     </a:p>
                   </a:txBody>
@@ -23063,7 +23063,7 @@
                     <a:p>
                       <a:r>
                         <a:rPr sz="1200" b="0"/>
-                        <a:t>save_wake_gif (frames → palette GIF)</a:t>
+                        <a:t>post-processing: Cd, Cl, St against the NASA Study #1 reference (VALIDATION_NASA.md)</a:t>
                       </a:r>
                     </a:p>
                   </a:txBody>

</xml_diff>